<commit_message>
feat: update project presentation
</commit_message>
<xml_diff>
--- a/Presentation.pptx
+++ b/Presentation.pptx
@@ -7,7 +7,7 @@
   <p:sldIdLst>
     <p:sldId id="256" r:id="rId2"/>
     <p:sldId id="257" r:id="rId3"/>
-    <p:sldId id="258" r:id="rId4"/>
+    <p:sldId id="264" r:id="rId4"/>
     <p:sldId id="259" r:id="rId5"/>
     <p:sldId id="260" r:id="rId6"/>
     <p:sldId id="261" r:id="rId7"/>
@@ -4862,14 +4862,6 @@
 <file path=ppt/slides/slide3.xml><?xml version="1.0" encoding="utf-8"?>
 <p:sld xmlns:a="http://schemas.openxmlformats.org/drawingml/2006/main" xmlns:r="http://schemas.openxmlformats.org/officeDocument/2006/relationships" xmlns:p="http://schemas.openxmlformats.org/presentationml/2006/main">
   <p:cSld>
-    <p:bg>
-      <p:bgPr>
-        <a:solidFill>
-          <a:srgbClr val="FFFFFF"/>
-        </a:solidFill>
-        <a:effectLst/>
-      </p:bgPr>
-    </p:bg>
     <p:spTree>
       <p:nvGrpSpPr>
         <p:cNvPr id="1" name=""/>
@@ -4886,27 +4878,21 @@
       </p:grpSpPr>
       <p:sp>
         <p:nvSpPr>
-          <p:cNvPr id="2" name="Rounded Rectangle 1"/>
+          <p:cNvPr id="2" name="Rectangle 1"/>
           <p:cNvSpPr/>
           <p:nvPr/>
         </p:nvSpPr>
         <p:spPr>
           <a:xfrm>
-            <a:off x="685800" y="2881312"/>
-            <a:ext cx="1813619" cy="1209675"/>
-          </a:xfrm>
-          <a:prstGeom prst="roundRect">
-            <a:avLst>
-              <a:gd name="adj" fmla="val 7874"/>
-            </a:avLst>
-          </a:prstGeom>
-          <a:solidFill>
-            <a:srgbClr val="F8FAFC"/>
-          </a:solidFill>
-          <a:ln w="9525">
-            <a:solidFill>
-              <a:srgbClr val="E2E8F0"/>
-            </a:solidFill>
+            <a:off x="533400" y="5806678"/>
+            <a:ext cx="11125200" cy="632221"/>
+          </a:xfrm>
+          <a:prstGeom prst="rect">
+            <a:avLst/>
+          </a:prstGeom>
+          <a:noFill/>
+          <a:ln>
+            <a:noFill/>
           </a:ln>
           <a:effectLst/>
         </p:spPr>
@@ -4935,27 +4921,21 @@
       </p:sp>
       <p:sp>
         <p:nvSpPr>
-          <p:cNvPr id="3" name="Rounded Rectangle 2"/>
+          <p:cNvPr id="3" name="Rectangle 2"/>
           <p:cNvSpPr/>
           <p:nvPr/>
         </p:nvSpPr>
         <p:spPr>
           <a:xfrm>
-            <a:off x="2937569" y="2881312"/>
-            <a:ext cx="1813619" cy="1209675"/>
-          </a:xfrm>
-          <a:prstGeom prst="roundRect">
-            <a:avLst>
-              <a:gd name="adj" fmla="val 7874"/>
-            </a:avLst>
-          </a:prstGeom>
-          <a:solidFill>
-            <a:srgbClr val="F8FAFC"/>
-          </a:solidFill>
-          <a:ln w="9525">
-            <a:solidFill>
-              <a:srgbClr val="E2E8F0"/>
-            </a:solidFill>
+            <a:off x="533400" y="5949553"/>
+            <a:ext cx="5391150" cy="489346"/>
+          </a:xfrm>
+          <a:prstGeom prst="rect">
+            <a:avLst/>
+          </a:prstGeom>
+          <a:noFill/>
+          <a:ln>
+            <a:noFill/>
           </a:ln>
           <a:effectLst/>
         </p:spPr>
@@ -4984,27 +4964,23 @@
       </p:sp>
       <p:sp>
         <p:nvSpPr>
-          <p:cNvPr id="4" name="Rounded Rectangle 3"/>
+          <p:cNvPr id="4" name="Rectangle 3"/>
           <p:cNvSpPr/>
           <p:nvPr/>
         </p:nvSpPr>
         <p:spPr>
           <a:xfrm>
-            <a:off x="5189339" y="2881312"/>
-            <a:ext cx="1813619" cy="1209675"/>
-          </a:xfrm>
-          <a:prstGeom prst="roundRect">
-            <a:avLst>
-              <a:gd name="adj" fmla="val 7874"/>
-            </a:avLst>
+            <a:off x="533400" y="5806678"/>
+            <a:ext cx="11125200" cy="9525"/>
+          </a:xfrm>
+          <a:prstGeom prst="rect">
+            <a:avLst/>
           </a:prstGeom>
           <a:solidFill>
-            <a:srgbClr val="F8FAFC"/>
+            <a:srgbClr val="F1F5F9"/>
           </a:solidFill>
-          <a:ln w="9525">
-            <a:solidFill>
-              <a:srgbClr val="E2E8F0"/>
-            </a:solidFill>
+          <a:ln>
+            <a:noFill/>
           </a:ln>
           <a:effectLst/>
         </p:spPr>
@@ -5033,27 +5009,21 @@
       </p:sp>
       <p:sp>
         <p:nvSpPr>
-          <p:cNvPr id="5" name="Rounded Rectangle 4"/>
+          <p:cNvPr id="5" name="Rectangle 4"/>
           <p:cNvSpPr/>
           <p:nvPr/>
         </p:nvSpPr>
         <p:spPr>
           <a:xfrm>
-            <a:off x="7441108" y="2881312"/>
-            <a:ext cx="1813619" cy="1209675"/>
-          </a:xfrm>
-          <a:prstGeom prst="roundRect">
-            <a:avLst>
-              <a:gd name="adj" fmla="val 7874"/>
-            </a:avLst>
-          </a:prstGeom>
-          <a:solidFill>
-            <a:srgbClr val="F8FAFC"/>
-          </a:solidFill>
-          <a:ln w="9525">
-            <a:solidFill>
-              <a:srgbClr val="E2E8F0"/>
-            </a:solidFill>
+            <a:off x="6267450" y="5949553"/>
+            <a:ext cx="5391150" cy="489346"/>
+          </a:xfrm>
+          <a:prstGeom prst="rect">
+            <a:avLst/>
+          </a:prstGeom>
+          <a:noFill/>
+          <a:ln>
+            <a:noFill/>
           </a:ln>
           <a:effectLst/>
         </p:spPr>
@@ -5088,21 +5058,19 @@
         </p:nvSpPr>
         <p:spPr>
           <a:xfrm>
-            <a:off x="9692878" y="2881312"/>
-            <a:ext cx="1813619" cy="1209675"/>
+            <a:off x="533400" y="1593353"/>
+            <a:ext cx="1579364" cy="190500"/>
           </a:xfrm>
           <a:prstGeom prst="roundRect">
             <a:avLst>
-              <a:gd name="adj" fmla="val 7874"/>
+              <a:gd name="adj" fmla="val 20000"/>
             </a:avLst>
           </a:prstGeom>
           <a:solidFill>
-            <a:srgbClr val="F8FAFC"/>
+            <a:srgbClr val="E0F2FE"/>
           </a:solidFill>
-          <a:ln w="9525">
-            <a:solidFill>
-              <a:srgbClr val="E2E8F0"/>
-            </a:solidFill>
+          <a:ln>
+            <a:noFill/>
           </a:ln>
           <a:effectLst/>
         </p:spPr>
@@ -5131,21 +5099,27 @@
       </p:sp>
       <p:sp>
         <p:nvSpPr>
-          <p:cNvPr id="7" name="Rectangle 6"/>
+          <p:cNvPr id="7" name="Rounded Rectangle 6"/>
           <p:cNvSpPr/>
           <p:nvPr/>
         </p:nvSpPr>
         <p:spPr>
           <a:xfrm>
-            <a:off x="685800" y="4357687"/>
-            <a:ext cx="5314950" cy="514350"/>
-          </a:xfrm>
-          <a:prstGeom prst="rect">
-            <a:avLst/>
-          </a:prstGeom>
-          <a:noFill/>
-          <a:ln>
-            <a:noFill/>
+            <a:off x="533400" y="1879103"/>
+            <a:ext cx="2011709" cy="1206698"/>
+          </a:xfrm>
+          <a:prstGeom prst="roundRect">
+            <a:avLst>
+              <a:gd name="adj" fmla="val 9472"/>
+            </a:avLst>
+          </a:prstGeom>
+          <a:solidFill>
+            <a:srgbClr val="F8FAFC"/>
+          </a:solidFill>
+          <a:ln w="9525">
+            <a:solidFill>
+              <a:srgbClr val="E2E8F0"/>
+            </a:solidFill>
           </a:ln>
           <a:effectLst/>
         </p:spPr>
@@ -5174,21 +5148,27 @@
       </p:sp>
       <p:sp>
         <p:nvSpPr>
-          <p:cNvPr id="8" name="Rectangle 7"/>
+          <p:cNvPr id="8" name="Rounded Rectangle 7"/>
           <p:cNvSpPr/>
           <p:nvPr/>
         </p:nvSpPr>
         <p:spPr>
           <a:xfrm>
-            <a:off x="6191250" y="4357687"/>
-            <a:ext cx="5314950" cy="514350"/>
-          </a:xfrm>
-          <a:prstGeom prst="rect">
-            <a:avLst/>
-          </a:prstGeom>
-          <a:noFill/>
-          <a:ln>
-            <a:noFill/>
+            <a:off x="2811809" y="1879103"/>
+            <a:ext cx="2011709" cy="1206698"/>
+          </a:xfrm>
+          <a:prstGeom prst="roundRect">
+            <a:avLst>
+              <a:gd name="adj" fmla="val 9472"/>
+            </a:avLst>
+          </a:prstGeom>
+          <a:solidFill>
+            <a:srgbClr val="F8FAFC"/>
+          </a:solidFill>
+          <a:ln w="9525">
+            <a:solidFill>
+              <a:srgbClr val="E2E8F0"/>
+            </a:solidFill>
           </a:ln>
           <a:effectLst/>
         </p:spPr>
@@ -5217,23 +5197,27 @@
       </p:sp>
       <p:sp>
         <p:nvSpPr>
-          <p:cNvPr id="9" name="Rectangle 8"/>
+          <p:cNvPr id="9" name="Rounded Rectangle 8"/>
           <p:cNvSpPr/>
           <p:nvPr/>
         </p:nvSpPr>
         <p:spPr>
           <a:xfrm>
-            <a:off x="685800" y="4357687"/>
-            <a:ext cx="28575" cy="514350"/>
-          </a:xfrm>
-          <a:prstGeom prst="rect">
-            <a:avLst/>
+            <a:off x="5090219" y="1879103"/>
+            <a:ext cx="2011709" cy="1206698"/>
+          </a:xfrm>
+          <a:prstGeom prst="roundRect">
+            <a:avLst>
+              <a:gd name="adj" fmla="val 9472"/>
+            </a:avLst>
           </a:prstGeom>
           <a:solidFill>
-            <a:srgbClr val="0284C7"/>
+            <a:srgbClr val="F8FAFC"/>
           </a:solidFill>
-          <a:ln>
-            <a:noFill/>
+          <a:ln w="9525">
+            <a:solidFill>
+              <a:srgbClr val="E2E8F0"/>
+            </a:solidFill>
           </a:ln>
           <a:effectLst/>
         </p:spPr>
@@ -5262,23 +5246,27 @@
       </p:sp>
       <p:sp>
         <p:nvSpPr>
-          <p:cNvPr id="10" name="Rectangle 9"/>
+          <p:cNvPr id="10" name="Rounded Rectangle 9"/>
           <p:cNvSpPr/>
           <p:nvPr/>
         </p:nvSpPr>
         <p:spPr>
           <a:xfrm>
-            <a:off x="6191250" y="4357687"/>
-            <a:ext cx="28575" cy="514350"/>
-          </a:xfrm>
-          <a:prstGeom prst="rect">
-            <a:avLst/>
+            <a:off x="7368629" y="1879103"/>
+            <a:ext cx="2011709" cy="1206698"/>
+          </a:xfrm>
+          <a:prstGeom prst="roundRect">
+            <a:avLst>
+              <a:gd name="adj" fmla="val 9472"/>
+            </a:avLst>
           </a:prstGeom>
           <a:solidFill>
-            <a:srgbClr val="10B981"/>
+            <a:srgbClr val="F8FAFC"/>
           </a:solidFill>
-          <a:ln>
-            <a:noFill/>
+          <a:ln w="9525">
+            <a:solidFill>
+              <a:srgbClr val="E2E8F0"/>
+            </a:solidFill>
           </a:ln>
           <a:effectLst/>
         </p:spPr>
@@ -5305,9 +5293,440 @@
           </a:p>
         </p:txBody>
       </p:sp>
+      <p:sp>
+        <p:nvSpPr>
+          <p:cNvPr id="11" name="Rounded Rectangle 10"/>
+          <p:cNvSpPr/>
+          <p:nvPr/>
+        </p:nvSpPr>
+        <p:spPr>
+          <a:xfrm>
+            <a:off x="9647039" y="1879103"/>
+            <a:ext cx="2011709" cy="1206698"/>
+          </a:xfrm>
+          <a:prstGeom prst="roundRect">
+            <a:avLst>
+              <a:gd name="adj" fmla="val 9472"/>
+            </a:avLst>
+          </a:prstGeom>
+          <a:solidFill>
+            <a:srgbClr val="F8FAFC"/>
+          </a:solidFill>
+          <a:ln w="9525">
+            <a:solidFill>
+              <a:srgbClr val="E2E8F0"/>
+            </a:solidFill>
+          </a:ln>
+          <a:effectLst/>
+        </p:spPr>
+        <p:style>
+          <a:lnRef idx="1">
+            <a:schemeClr val="accent1"/>
+          </a:lnRef>
+          <a:fillRef idx="3">
+            <a:schemeClr val="accent1"/>
+          </a:fillRef>
+          <a:effectRef idx="2">
+            <a:schemeClr val="accent1"/>
+          </a:effectRef>
+          <a:fontRef idx="minor">
+            <a:schemeClr val="lt1"/>
+          </a:fontRef>
+        </p:style>
+        <p:txBody>
+          <a:bodyPr rtlCol="0" anchor="ctr"/>
+          <a:lstStyle/>
+          <a:p>
+            <a:pPr algn="ctr"/>
+            <a:endParaRPr/>
+          </a:p>
+        </p:txBody>
+      </p:sp>
+      <p:sp>
+        <p:nvSpPr>
+          <p:cNvPr id="12" name="Rounded Rectangle 11"/>
+          <p:cNvSpPr/>
+          <p:nvPr/>
+        </p:nvSpPr>
+        <p:spPr>
+          <a:xfrm>
+            <a:off x="533400" y="3700016"/>
+            <a:ext cx="1682204" cy="190500"/>
+          </a:xfrm>
+          <a:prstGeom prst="roundRect">
+            <a:avLst>
+              <a:gd name="adj" fmla="val 20000"/>
+            </a:avLst>
+          </a:prstGeom>
+          <a:solidFill>
+            <a:srgbClr val="DCFCE7"/>
+          </a:solidFill>
+          <a:ln>
+            <a:noFill/>
+          </a:ln>
+          <a:effectLst/>
+        </p:spPr>
+        <p:style>
+          <a:lnRef idx="1">
+            <a:schemeClr val="accent1"/>
+          </a:lnRef>
+          <a:fillRef idx="3">
+            <a:schemeClr val="accent1"/>
+          </a:fillRef>
+          <a:effectRef idx="2">
+            <a:schemeClr val="accent1"/>
+          </a:effectRef>
+          <a:fontRef idx="minor">
+            <a:schemeClr val="lt1"/>
+          </a:fontRef>
+        </p:style>
+        <p:txBody>
+          <a:bodyPr rtlCol="0" anchor="ctr"/>
+          <a:lstStyle/>
+          <a:p>
+            <a:pPr algn="ctr"/>
+            <a:endParaRPr/>
+          </a:p>
+        </p:txBody>
+      </p:sp>
+      <p:sp>
+        <p:nvSpPr>
+          <p:cNvPr id="13" name="Rounded Rectangle 12"/>
+          <p:cNvSpPr/>
+          <p:nvPr/>
+        </p:nvSpPr>
+        <p:spPr>
+          <a:xfrm>
+            <a:off x="533400" y="3985766"/>
+            <a:ext cx="2011709" cy="1206698"/>
+          </a:xfrm>
+          <a:prstGeom prst="roundRect">
+            <a:avLst>
+              <a:gd name="adj" fmla="val 9472"/>
+            </a:avLst>
+          </a:prstGeom>
+          <a:solidFill>
+            <a:srgbClr val="F8FAFC"/>
+          </a:solidFill>
+          <a:ln w="9525">
+            <a:solidFill>
+              <a:srgbClr val="E2E8F0"/>
+            </a:solidFill>
+          </a:ln>
+          <a:effectLst/>
+        </p:spPr>
+        <p:style>
+          <a:lnRef idx="1">
+            <a:schemeClr val="accent1"/>
+          </a:lnRef>
+          <a:fillRef idx="3">
+            <a:schemeClr val="accent1"/>
+          </a:fillRef>
+          <a:effectRef idx="2">
+            <a:schemeClr val="accent1"/>
+          </a:effectRef>
+          <a:fontRef idx="minor">
+            <a:schemeClr val="lt1"/>
+          </a:fontRef>
+        </p:style>
+        <p:txBody>
+          <a:bodyPr rtlCol="0" anchor="ctr"/>
+          <a:lstStyle/>
+          <a:p>
+            <a:pPr algn="ctr"/>
+            <a:endParaRPr/>
+          </a:p>
+        </p:txBody>
+      </p:sp>
+      <p:sp>
+        <p:nvSpPr>
+          <p:cNvPr id="14" name="Rounded Rectangle 13"/>
+          <p:cNvSpPr/>
+          <p:nvPr/>
+        </p:nvSpPr>
+        <p:spPr>
+          <a:xfrm>
+            <a:off x="2811809" y="3985766"/>
+            <a:ext cx="2011709" cy="1206698"/>
+          </a:xfrm>
+          <a:prstGeom prst="roundRect">
+            <a:avLst>
+              <a:gd name="adj" fmla="val 9472"/>
+            </a:avLst>
+          </a:prstGeom>
+          <a:solidFill>
+            <a:srgbClr val="F8FAFC"/>
+          </a:solidFill>
+          <a:ln w="9525">
+            <a:solidFill>
+              <a:srgbClr val="E2E8F0"/>
+            </a:solidFill>
+          </a:ln>
+          <a:effectLst/>
+        </p:spPr>
+        <p:style>
+          <a:lnRef idx="1">
+            <a:schemeClr val="accent1"/>
+          </a:lnRef>
+          <a:fillRef idx="3">
+            <a:schemeClr val="accent1"/>
+          </a:fillRef>
+          <a:effectRef idx="2">
+            <a:schemeClr val="accent1"/>
+          </a:effectRef>
+          <a:fontRef idx="minor">
+            <a:schemeClr val="lt1"/>
+          </a:fontRef>
+        </p:style>
+        <p:txBody>
+          <a:bodyPr rtlCol="0" anchor="ctr"/>
+          <a:lstStyle/>
+          <a:p>
+            <a:pPr algn="ctr"/>
+            <a:endParaRPr/>
+          </a:p>
+        </p:txBody>
+      </p:sp>
+      <p:sp>
+        <p:nvSpPr>
+          <p:cNvPr id="15" name="Rounded Rectangle 14"/>
+          <p:cNvSpPr/>
+          <p:nvPr/>
+        </p:nvSpPr>
+        <p:spPr>
+          <a:xfrm>
+            <a:off x="5090219" y="3985766"/>
+            <a:ext cx="2011709" cy="1206698"/>
+          </a:xfrm>
+          <a:prstGeom prst="roundRect">
+            <a:avLst>
+              <a:gd name="adj" fmla="val 9472"/>
+            </a:avLst>
+          </a:prstGeom>
+          <a:solidFill>
+            <a:srgbClr val="F8FAFC"/>
+          </a:solidFill>
+          <a:ln w="9525">
+            <a:solidFill>
+              <a:srgbClr val="E2E8F0"/>
+            </a:solidFill>
+          </a:ln>
+          <a:effectLst/>
+        </p:spPr>
+        <p:style>
+          <a:lnRef idx="1">
+            <a:schemeClr val="accent1"/>
+          </a:lnRef>
+          <a:fillRef idx="3">
+            <a:schemeClr val="accent1"/>
+          </a:fillRef>
+          <a:effectRef idx="2">
+            <a:schemeClr val="accent1"/>
+          </a:effectRef>
+          <a:fontRef idx="minor">
+            <a:schemeClr val="lt1"/>
+          </a:fontRef>
+        </p:style>
+        <p:txBody>
+          <a:bodyPr rtlCol="0" anchor="ctr"/>
+          <a:lstStyle/>
+          <a:p>
+            <a:pPr algn="ctr"/>
+            <a:endParaRPr/>
+          </a:p>
+        </p:txBody>
+      </p:sp>
+      <p:sp>
+        <p:nvSpPr>
+          <p:cNvPr id="16" name="Rounded Rectangle 15"/>
+          <p:cNvSpPr/>
+          <p:nvPr/>
+        </p:nvSpPr>
+        <p:spPr>
+          <a:xfrm>
+            <a:off x="7368629" y="3985766"/>
+            <a:ext cx="2011709" cy="1206698"/>
+          </a:xfrm>
+          <a:prstGeom prst="roundRect">
+            <a:avLst>
+              <a:gd name="adj" fmla="val 9472"/>
+            </a:avLst>
+          </a:prstGeom>
+          <a:solidFill>
+            <a:srgbClr val="F8FAFC"/>
+          </a:solidFill>
+          <a:ln w="9525">
+            <a:solidFill>
+              <a:srgbClr val="E2E8F0"/>
+            </a:solidFill>
+          </a:ln>
+          <a:effectLst/>
+        </p:spPr>
+        <p:style>
+          <a:lnRef idx="1">
+            <a:schemeClr val="accent1"/>
+          </a:lnRef>
+          <a:fillRef idx="3">
+            <a:schemeClr val="accent1"/>
+          </a:fillRef>
+          <a:effectRef idx="2">
+            <a:schemeClr val="accent1"/>
+          </a:effectRef>
+          <a:fontRef idx="minor">
+            <a:schemeClr val="lt1"/>
+          </a:fontRef>
+        </p:style>
+        <p:txBody>
+          <a:bodyPr rtlCol="0" anchor="ctr"/>
+          <a:lstStyle/>
+          <a:p>
+            <a:pPr algn="ctr"/>
+            <a:endParaRPr/>
+          </a:p>
+        </p:txBody>
+      </p:sp>
+      <p:sp>
+        <p:nvSpPr>
+          <p:cNvPr id="17" name="Rounded Rectangle 16"/>
+          <p:cNvSpPr/>
+          <p:nvPr/>
+        </p:nvSpPr>
+        <p:spPr>
+          <a:xfrm>
+            <a:off x="9647039" y="3985766"/>
+            <a:ext cx="2011709" cy="1206698"/>
+          </a:xfrm>
+          <a:prstGeom prst="roundRect">
+            <a:avLst>
+              <a:gd name="adj" fmla="val 9472"/>
+            </a:avLst>
+          </a:prstGeom>
+          <a:solidFill>
+            <a:srgbClr val="F8FAFC"/>
+          </a:solidFill>
+          <a:ln w="9525">
+            <a:solidFill>
+              <a:srgbClr val="E2E8F0"/>
+            </a:solidFill>
+          </a:ln>
+          <a:effectLst/>
+        </p:spPr>
+        <p:style>
+          <a:lnRef idx="1">
+            <a:schemeClr val="accent1"/>
+          </a:lnRef>
+          <a:fillRef idx="3">
+            <a:schemeClr val="accent1"/>
+          </a:fillRef>
+          <a:effectRef idx="2">
+            <a:schemeClr val="accent1"/>
+          </a:effectRef>
+          <a:fontRef idx="minor">
+            <a:schemeClr val="lt1"/>
+          </a:fontRef>
+        </p:style>
+        <p:txBody>
+          <a:bodyPr rtlCol="0" anchor="ctr"/>
+          <a:lstStyle/>
+          <a:p>
+            <a:pPr algn="ctr"/>
+            <a:endParaRPr/>
+          </a:p>
+        </p:txBody>
+      </p:sp>
+      <p:sp>
+        <p:nvSpPr>
+          <p:cNvPr id="18" name="Rectangle 17"/>
+          <p:cNvSpPr/>
+          <p:nvPr/>
+        </p:nvSpPr>
+        <p:spPr>
+          <a:xfrm>
+            <a:off x="533400" y="5949553"/>
+            <a:ext cx="28575" cy="489346"/>
+          </a:xfrm>
+          <a:prstGeom prst="rect">
+            <a:avLst/>
+          </a:prstGeom>
+          <a:solidFill>
+            <a:srgbClr val="0284C7"/>
+          </a:solidFill>
+          <a:ln>
+            <a:noFill/>
+          </a:ln>
+          <a:effectLst/>
+        </p:spPr>
+        <p:style>
+          <a:lnRef idx="1">
+            <a:schemeClr val="accent1"/>
+          </a:lnRef>
+          <a:fillRef idx="3">
+            <a:schemeClr val="accent1"/>
+          </a:fillRef>
+          <a:effectRef idx="2">
+            <a:schemeClr val="accent1"/>
+          </a:effectRef>
+          <a:fontRef idx="minor">
+            <a:schemeClr val="lt1"/>
+          </a:fontRef>
+        </p:style>
+        <p:txBody>
+          <a:bodyPr rtlCol="0" anchor="ctr"/>
+          <a:lstStyle/>
+          <a:p>
+            <a:pPr algn="ctr"/>
+            <a:endParaRPr/>
+          </a:p>
+        </p:txBody>
+      </p:sp>
+      <p:sp>
+        <p:nvSpPr>
+          <p:cNvPr id="19" name="Rectangle 18"/>
+          <p:cNvSpPr/>
+          <p:nvPr/>
+        </p:nvSpPr>
+        <p:spPr>
+          <a:xfrm>
+            <a:off x="6267450" y="5949553"/>
+            <a:ext cx="28575" cy="489346"/>
+          </a:xfrm>
+          <a:prstGeom prst="rect">
+            <a:avLst/>
+          </a:prstGeom>
+          <a:solidFill>
+            <a:srgbClr val="059669"/>
+          </a:solidFill>
+          <a:ln>
+            <a:noFill/>
+          </a:ln>
+          <a:effectLst/>
+        </p:spPr>
+        <p:style>
+          <a:lnRef idx="1">
+            <a:schemeClr val="accent1"/>
+          </a:lnRef>
+          <a:fillRef idx="3">
+            <a:schemeClr val="accent1"/>
+          </a:fillRef>
+          <a:effectRef idx="2">
+            <a:schemeClr val="accent1"/>
+          </a:effectRef>
+          <a:fontRef idx="minor">
+            <a:schemeClr val="lt1"/>
+          </a:fontRef>
+        </p:style>
+        <p:txBody>
+          <a:bodyPr rtlCol="0" anchor="ctr"/>
+          <a:lstStyle/>
+          <a:p>
+            <a:pPr algn="ctr"/>
+            <a:endParaRPr/>
+          </a:p>
+        </p:txBody>
+      </p:sp>
       <p:pic>
         <p:nvPicPr>
-          <p:cNvPr id="11" name="Picture 10" descr="image.png"/>
+          <p:cNvPr id="20" name="Picture 19" descr="image.png"/>
           <p:cNvPicPr>
             <a:picLocks noChangeAspect="1"/>
           </p:cNvPicPr>
@@ -5321,8 +5740,8 @@
         </p:blipFill>
         <p:spPr>
           <a:xfrm>
-            <a:off x="2651819" y="3409950"/>
-            <a:ext cx="133350" cy="152400"/>
+            <a:off x="2621309" y="2415778"/>
+            <a:ext cx="114300" cy="133350"/>
           </a:xfrm>
           <a:prstGeom prst="rect">
             <a:avLst/>
@@ -5331,7 +5750,31 @@
       </p:pic>
       <p:pic>
         <p:nvPicPr>
-          <p:cNvPr id="12" name="Picture 11" descr="image.png"/>
+          <p:cNvPr id="21" name="Picture 20" descr="image.png"/>
+          <p:cNvPicPr>
+            <a:picLocks noChangeAspect="1"/>
+          </p:cNvPicPr>
+          <p:nvPr/>
+        </p:nvPicPr>
+        <p:blipFill>
+          <a:blip r:embed="rId2"/>
+          <a:stretch>
+            <a:fillRect/>
+          </a:stretch>
+        </p:blipFill>
+        <p:spPr>
+          <a:xfrm>
+            <a:off x="4899719" y="2415778"/>
+            <a:ext cx="114300" cy="133350"/>
+          </a:xfrm>
+          <a:prstGeom prst="rect">
+            <a:avLst/>
+          </a:prstGeom>
+        </p:spPr>
+      </p:pic>
+      <p:pic>
+        <p:nvPicPr>
+          <p:cNvPr id="22" name="Picture 21" descr="image.png"/>
           <p:cNvPicPr>
             <a:picLocks noChangeAspect="1"/>
           </p:cNvPicPr>
@@ -5345,8 +5788,8 @@
         </p:blipFill>
         <p:spPr>
           <a:xfrm>
-            <a:off x="4903589" y="3409950"/>
-            <a:ext cx="133350" cy="152400"/>
+            <a:off x="7178129" y="2415778"/>
+            <a:ext cx="114300" cy="133350"/>
           </a:xfrm>
           <a:prstGeom prst="rect">
             <a:avLst/>
@@ -5355,7 +5798,31 @@
       </p:pic>
       <p:pic>
         <p:nvPicPr>
-          <p:cNvPr id="13" name="Picture 12" descr="image.png"/>
+          <p:cNvPr id="23" name="Picture 22" descr="image.png"/>
+          <p:cNvPicPr>
+            <a:picLocks noChangeAspect="1"/>
+          </p:cNvPicPr>
+          <p:nvPr/>
+        </p:nvPicPr>
+        <p:blipFill>
+          <a:blip r:embed="rId3"/>
+          <a:stretch>
+            <a:fillRect/>
+          </a:stretch>
+        </p:blipFill>
+        <p:spPr>
+          <a:xfrm>
+            <a:off x="9456539" y="2415778"/>
+            <a:ext cx="114300" cy="133350"/>
+          </a:xfrm>
+          <a:prstGeom prst="rect">
+            <a:avLst/>
+          </a:prstGeom>
+        </p:spPr>
+      </p:pic>
+      <p:pic>
+        <p:nvPicPr>
+          <p:cNvPr id="24" name="Picture 23" descr="image.png"/>
           <p:cNvPicPr>
             <a:picLocks noChangeAspect="1"/>
           </p:cNvPicPr>
@@ -5369,8 +5836,8 @@
         </p:blipFill>
         <p:spPr>
           <a:xfrm>
-            <a:off x="7155358" y="3409950"/>
-            <a:ext cx="133350" cy="152400"/>
+            <a:off x="2621309" y="4522440"/>
+            <a:ext cx="114300" cy="133350"/>
           </a:xfrm>
           <a:prstGeom prst="rect">
             <a:avLst/>
@@ -5379,7 +5846,31 @@
       </p:pic>
       <p:pic>
         <p:nvPicPr>
-          <p:cNvPr id="14" name="Picture 13" descr="image.png"/>
+          <p:cNvPr id="25" name="Picture 24" descr="image.png"/>
+          <p:cNvPicPr>
+            <a:picLocks noChangeAspect="1"/>
+          </p:cNvPicPr>
+          <p:nvPr/>
+        </p:nvPicPr>
+        <p:blipFill>
+          <a:blip r:embed="rId2"/>
+          <a:stretch>
+            <a:fillRect/>
+          </a:stretch>
+        </p:blipFill>
+        <p:spPr>
+          <a:xfrm>
+            <a:off x="4899719" y="4522440"/>
+            <a:ext cx="114300" cy="133350"/>
+          </a:xfrm>
+          <a:prstGeom prst="rect">
+            <a:avLst/>
+          </a:prstGeom>
+        </p:spPr>
+      </p:pic>
+      <p:pic>
+        <p:nvPicPr>
+          <p:cNvPr id="26" name="Picture 25" descr="image.png"/>
           <p:cNvPicPr>
             <a:picLocks noChangeAspect="1"/>
           </p:cNvPicPr>
@@ -5393,24 +5884,48 @@
         </p:blipFill>
         <p:spPr>
           <a:xfrm>
-            <a:off x="9407128" y="3409950"/>
-            <a:ext cx="133350" cy="152400"/>
+            <a:off x="7178129" y="4522440"/>
+            <a:ext cx="114300" cy="133350"/>
           </a:xfrm>
           <a:prstGeom prst="rect">
             <a:avLst/>
           </a:prstGeom>
         </p:spPr>
       </p:pic>
-      <p:sp>
-        <p:nvSpPr>
-          <p:cNvPr id="15" name="TextBox 14"/>
+      <p:pic>
+        <p:nvPicPr>
+          <p:cNvPr id="27" name="Picture 26" descr="image.png"/>
+          <p:cNvPicPr>
+            <a:picLocks noChangeAspect="1"/>
+          </p:cNvPicPr>
+          <p:nvPr/>
+        </p:nvPicPr>
+        <p:blipFill>
+          <a:blip r:embed="rId3"/>
+          <a:stretch>
+            <a:fillRect/>
+          </a:stretch>
+        </p:blipFill>
+        <p:spPr>
+          <a:xfrm>
+            <a:off x="9456539" y="4522440"/>
+            <a:ext cx="114300" cy="133350"/>
+          </a:xfrm>
+          <a:prstGeom prst="rect">
+            <a:avLst/>
+          </a:prstGeom>
+        </p:spPr>
+      </p:pic>
+      <p:sp>
+        <p:nvSpPr>
+          <p:cNvPr id="28" name="TextBox 27"/>
           <p:cNvSpPr txBox="1"/>
           <p:nvPr/>
         </p:nvSpPr>
         <p:spPr>
           <a:xfrm>
-            <a:off x="685800" y="457200"/>
-            <a:ext cx="11506200" cy="152400"/>
+            <a:off x="533400" y="419100"/>
+            <a:ext cx="11658600" cy="152400"/>
           </a:xfrm>
           <a:prstGeom prst="rect">
             <a:avLst/>
@@ -5429,7 +5944,7 @@
                 <a:solidFill>
                   <a:srgbClr val="0284C7"/>
                 </a:solidFill>
-                <a:latin typeface="Plus Jakarta Sans"/>
+                <a:latin typeface="Inter"/>
               </a:rPr>
               <a:t>SYSTEM ARCHITECTURE</a:t>
             </a:r>
@@ -5438,14 +5953,14 @@
       </p:sp>
       <p:sp>
         <p:nvSpPr>
-          <p:cNvPr id="16" name="TextBox 15"/>
+          <p:cNvPr id="29" name="TextBox 28"/>
           <p:cNvSpPr txBox="1"/>
           <p:nvPr/>
         </p:nvSpPr>
         <p:spPr>
           <a:xfrm>
-            <a:off x="685800" y="666750"/>
-            <a:ext cx="11506200" cy="381000"/>
+            <a:off x="533400" y="628650"/>
+            <a:ext cx="11658600" cy="350490"/>
           </a:xfrm>
           <a:prstGeom prst="rect">
             <a:avLst/>
@@ -5458,29 +5973,68 @@
           </a:bodyPr>
           <a:lstStyle/>
           <a:p>
-            <a:pPr algn="l"/>
+            <a:pPr algn="l">
+              <a:lnSpc>
+                <a:spcPts val="2760"/>
+              </a:lnSpc>
+            </a:pPr>
             <a:r>
               <a:rPr sz="2400" b="1" i="0" u="none">
                 <a:solidFill>
                   <a:srgbClr val="0F172A"/>
                 </a:solidFill>
-                <a:latin typeface="Plus Jakarta Sans"/>
+                <a:latin typeface="Inter"/>
               </a:rPr>
-              <a:t>Inspection Pipeline Workflow</a:t>
-            </a:r>
-          </a:p>
-        </p:txBody>
-      </p:sp>
-      <p:sp>
-        <p:nvSpPr>
-          <p:cNvPr id="17" name="TextBox 16"/>
+              <a:t>End-to-End Pipeline Workflow</a:t>
+            </a:r>
+          </a:p>
+        </p:txBody>
+      </p:sp>
+      <p:sp>
+        <p:nvSpPr>
+          <p:cNvPr id="30" name="TextBox 29"/>
           <p:cNvSpPr txBox="1"/>
           <p:nvPr/>
         </p:nvSpPr>
         <p:spPr>
           <a:xfrm>
-            <a:off x="685316" y="3100387"/>
-            <a:ext cx="1814586" cy="152400"/>
+            <a:off x="609600" y="1621928"/>
+            <a:ext cx="1522214" cy="133350"/>
+          </a:xfrm>
+          <a:prstGeom prst="rect">
+            <a:avLst/>
+          </a:prstGeom>
+          <a:noFill/>
+        </p:spPr>
+        <p:txBody>
+          <a:bodyPr wrap="square" lIns="0" tIns="0" rIns="0" bIns="0" anchor="t">
+            <a:spAutoFit/>
+          </a:bodyPr>
+          <a:lstStyle/>
+          <a:p>
+            <a:pPr algn="l"/>
+            <a:r>
+              <a:rPr sz="825" b="1" i="0" u="none">
+                <a:solidFill>
+                  <a:srgbClr val="0369A1"/>
+                </a:solidFill>
+                <a:latin typeface="Inter"/>
+              </a:rPr>
+              <a:t>OFFLINE TRAINING FLOW</a:t>
+            </a:r>
+          </a:p>
+        </p:txBody>
+      </p:sp>
+      <p:sp>
+        <p:nvSpPr>
+          <p:cNvPr id="31" name="TextBox 30"/>
+          <p:cNvSpPr txBox="1"/>
+          <p:nvPr/>
+        </p:nvSpPr>
+        <p:spPr>
+          <a:xfrm>
+            <a:off x="2208014" y="1612403"/>
+            <a:ext cx="4441031" cy="152400"/>
           </a:xfrm>
           <a:prstGeom prst="rect">
             <a:avLst/>
@@ -5493,29 +6047,282 @@
           </a:bodyPr>
           <a:lstStyle/>
           <a:p>
+            <a:pPr algn="l"/>
+            <a:r>
+              <a:rPr sz="975" b="1" i="0" u="none">
+                <a:solidFill>
+                  <a:srgbClr val="64748B"/>
+                </a:solidFill>
+                <a:latin typeface="Inter"/>
+              </a:rPr>
+              <a:t>209 Normal Bottles • Rapid CPU Moment Estimation (~3.5s)</a:t>
+            </a:r>
+          </a:p>
+        </p:txBody>
+      </p:sp>
+      <p:sp>
+        <p:nvSpPr>
+          <p:cNvPr id="32" name="TextBox 31"/>
+          <p:cNvSpPr txBox="1"/>
+          <p:nvPr/>
+        </p:nvSpPr>
+        <p:spPr>
+          <a:xfrm>
+            <a:off x="609600" y="3728591"/>
+            <a:ext cx="1625054" cy="133350"/>
+          </a:xfrm>
+          <a:prstGeom prst="rect">
+            <a:avLst/>
+          </a:prstGeom>
+          <a:noFill/>
+        </p:spPr>
+        <p:txBody>
+          <a:bodyPr wrap="square" lIns="0" tIns="0" rIns="0" bIns="0" anchor="t">
+            <a:spAutoFit/>
+          </a:bodyPr>
+          <a:lstStyle/>
+          <a:p>
+            <a:pPr algn="l"/>
+            <a:r>
+              <a:rPr sz="825" b="1" i="0" u="none">
+                <a:solidFill>
+                  <a:srgbClr val="15803D"/>
+                </a:solidFill>
+                <a:latin typeface="Inter"/>
+              </a:rPr>
+              <a:t>ONLINE INSPECTION FLOW</a:t>
+            </a:r>
+          </a:p>
+        </p:txBody>
+      </p:sp>
+      <p:sp>
+        <p:nvSpPr>
+          <p:cNvPr id="33" name="TextBox 32"/>
+          <p:cNvSpPr txBox="1"/>
+          <p:nvPr/>
+        </p:nvSpPr>
+        <p:spPr>
+          <a:xfrm>
+            <a:off x="2310854" y="3719066"/>
+            <a:ext cx="3845718" cy="152400"/>
+          </a:xfrm>
+          <a:prstGeom prst="rect">
+            <a:avLst/>
+          </a:prstGeom>
+          <a:noFill/>
+        </p:spPr>
+        <p:txBody>
+          <a:bodyPr wrap="none" lIns="0" tIns="0" rIns="0" bIns="0" anchor="t">
+            <a:spAutoFit/>
+          </a:bodyPr>
+          <a:lstStyle/>
+          <a:p>
+            <a:pPr algn="l"/>
+            <a:r>
+              <a:rPr sz="975" b="1" i="0" u="none">
+                <a:solidFill>
+                  <a:srgbClr val="64748B"/>
+                </a:solidFill>
+                <a:latin typeface="Inter"/>
+              </a:rPr>
+              <a:t>Real-Time Factory Edge Inference (~28 ms / frame)</a:t>
+            </a:r>
+          </a:p>
+        </p:txBody>
+      </p:sp>
+      <p:sp>
+        <p:nvSpPr>
+          <p:cNvPr id="34" name="TextBox 33"/>
+          <p:cNvSpPr txBox="1"/>
+          <p:nvPr/>
+        </p:nvSpPr>
+        <p:spPr>
+          <a:xfrm>
+            <a:off x="695325" y="5949553"/>
+            <a:ext cx="6863357" cy="152400"/>
+          </a:xfrm>
+          <a:prstGeom prst="rect">
+            <a:avLst/>
+          </a:prstGeom>
+          <a:noFill/>
+        </p:spPr>
+        <p:txBody>
+          <a:bodyPr wrap="none" lIns="0" tIns="0" rIns="0" bIns="0" anchor="t">
+            <a:spAutoFit/>
+          </a:bodyPr>
+          <a:lstStyle/>
+          <a:p>
+            <a:pPr algn="l"/>
+            <a:r>
+              <a:rPr sz="1012" b="1" i="0" u="none">
+                <a:solidFill>
+                  <a:srgbClr val="0F172A"/>
+                </a:solidFill>
+                <a:latin typeface="Inter"/>
+              </a:rPr>
+              <a:t>Affine Drift Correction</a:t>
+            </a:r>
+          </a:p>
+        </p:txBody>
+      </p:sp>
+      <p:sp>
+        <p:nvSpPr>
+          <p:cNvPr id="35" name="TextBox 34"/>
+          <p:cNvSpPr txBox="1"/>
+          <p:nvPr/>
+        </p:nvSpPr>
+        <p:spPr>
+          <a:xfrm>
+            <a:off x="695325" y="6130528"/>
+            <a:ext cx="6536531" cy="154185"/>
+          </a:xfrm>
+          <a:prstGeom prst="rect">
+            <a:avLst/>
+          </a:prstGeom>
+          <a:noFill/>
+        </p:spPr>
+        <p:txBody>
+          <a:bodyPr wrap="none" lIns="0" tIns="0" rIns="0" bIns="0" anchor="t">
+            <a:spAutoFit/>
+          </a:bodyPr>
+          <a:lstStyle/>
+          <a:p>
+            <a:pPr algn="l">
+              <a:lnSpc>
+                <a:spcPts val="1214"/>
+              </a:lnSpc>
+            </a:pPr>
+            <a:r>
+              <a:rPr sz="900" b="0" i="0" u="none">
+                <a:solidFill>
+                  <a:srgbClr val="64748B"/>
+                </a:solidFill>
+                <a:latin typeface="Inter"/>
+              </a:rPr>
+              <a:t>Cancels conveyor belt displacement to sub-pixel coordinates across both training and inference.</a:t>
+            </a:r>
+          </a:p>
+        </p:txBody>
+      </p:sp>
+      <p:sp>
+        <p:nvSpPr>
+          <p:cNvPr id="36" name="TextBox 35"/>
+          <p:cNvSpPr txBox="1"/>
+          <p:nvPr/>
+        </p:nvSpPr>
+        <p:spPr>
+          <a:xfrm>
+            <a:off x="6429375" y="5949553"/>
+            <a:ext cx="5762625" cy="152400"/>
+          </a:xfrm>
+          <a:prstGeom prst="rect">
+            <a:avLst/>
+          </a:prstGeom>
+          <a:noFill/>
+        </p:spPr>
+        <p:txBody>
+          <a:bodyPr wrap="none" lIns="0" tIns="0" rIns="0" bIns="0" anchor="t">
+            <a:spAutoFit/>
+          </a:bodyPr>
+          <a:lstStyle/>
+          <a:p>
+            <a:pPr algn="l"/>
+            <a:r>
+              <a:rPr sz="1012" b="1" i="0" u="none">
+                <a:solidFill>
+                  <a:srgbClr val="0F172A"/>
+                </a:solidFill>
+                <a:latin typeface="Inter"/>
+              </a:rPr>
+              <a:t>One-Class Statistical Distribution</a:t>
+            </a:r>
+          </a:p>
+        </p:txBody>
+      </p:sp>
+      <p:sp>
+        <p:nvSpPr>
+          <p:cNvPr id="37" name="TextBox 36"/>
+          <p:cNvSpPr txBox="1"/>
+          <p:nvPr/>
+        </p:nvSpPr>
+        <p:spPr>
+          <a:xfrm>
+            <a:off x="6429375" y="6130528"/>
+            <a:ext cx="5324475" cy="308371"/>
+          </a:xfrm>
+          <a:prstGeom prst="rect">
+            <a:avLst/>
+          </a:prstGeom>
+          <a:noFill/>
+        </p:spPr>
+        <p:txBody>
+          <a:bodyPr wrap="square" lIns="0" tIns="0" rIns="0" bIns="0" anchor="t">
+            <a:spAutoFit/>
+          </a:bodyPr>
+          <a:lstStyle/>
+          <a:p>
+            <a:pPr algn="l">
+              <a:lnSpc>
+                <a:spcPts val="1214"/>
+              </a:lnSpc>
+            </a:pPr>
+            <a:r>
+              <a:rPr sz="900" b="0" i="0" u="none">
+                <a:solidFill>
+                  <a:srgbClr val="64748B"/>
+                </a:solidFill>
+                <a:latin typeface="Inter"/>
+              </a:rPr>
+              <a:t>Fits spatial mean and variance solely on 209 defect-free samples, eliminating the need for defective training data.</a:t>
+            </a:r>
+          </a:p>
+        </p:txBody>
+      </p:sp>
+      <p:sp>
+        <p:nvSpPr>
+          <p:cNvPr id="38" name="TextBox 37"/>
+          <p:cNvSpPr txBox="1"/>
+          <p:nvPr/>
+        </p:nvSpPr>
+        <p:spPr>
+          <a:xfrm>
+            <a:off x="460530" y="2041028"/>
+            <a:ext cx="2157449" cy="133350"/>
+          </a:xfrm>
+          <a:prstGeom prst="rect">
+            <a:avLst/>
+          </a:prstGeom>
+          <a:noFill/>
+        </p:spPr>
+        <p:txBody>
+          <a:bodyPr wrap="none" lIns="0" tIns="0" rIns="0" bIns="0" anchor="t">
+            <a:spAutoFit/>
+          </a:bodyPr>
+          <a:lstStyle/>
+          <a:p>
             <a:pPr algn="ctr"/>
             <a:r>
-              <a:rPr sz="900" b="1" i="0" u="none">
+              <a:rPr sz="825" b="1" i="0" u="none">
                 <a:solidFill>
                   <a:srgbClr val="0284C7"/>
                 </a:solidFill>
-                <a:latin typeface="JetBrains Mono"/>
+                <a:latin typeface="Inter"/>
               </a:rPr>
-              <a:t>STEP 01</a:t>
-            </a:r>
-          </a:p>
-        </p:txBody>
-      </p:sp>
-      <p:sp>
-        <p:nvSpPr>
-          <p:cNvPr id="18" name="TextBox 17"/>
+              <a:t>STEP T1</a:t>
+            </a:r>
+          </a:p>
+        </p:txBody>
+      </p:sp>
+      <p:sp>
+        <p:nvSpPr>
+          <p:cNvPr id="39" name="TextBox 38"/>
           <p:cNvSpPr txBox="1"/>
           <p:nvPr/>
         </p:nvSpPr>
         <p:spPr>
           <a:xfrm>
-            <a:off x="639951" y="3309937"/>
-            <a:ext cx="1905316" cy="200025"/>
+            <a:off x="406593" y="2231528"/>
+            <a:ext cx="2265322" cy="172640"/>
           </a:xfrm>
           <a:prstGeom prst="rect">
             <a:avLst/>
@@ -5528,29 +6335,33 @@
           </a:bodyPr>
           <a:lstStyle/>
           <a:p>
-            <a:pPr algn="ctr"/>
-            <a:r>
-              <a:rPr sz="1200" b="1" i="0" u="none">
+            <a:pPr algn="ctr">
+              <a:lnSpc>
+                <a:spcPts val="1359"/>
+              </a:lnSpc>
+            </a:pPr>
+            <a:r>
+              <a:rPr sz="1087" b="1" i="0" u="none">
                 <a:solidFill>
                   <a:srgbClr val="0F172A"/>
                 </a:solidFill>
-                <a:latin typeface="Plus Jakarta Sans"/>
+                <a:latin typeface="Inter"/>
               </a:rPr>
-              <a:t>Input &amp; Resizing</a:t>
-            </a:r>
-          </a:p>
-        </p:txBody>
-      </p:sp>
-      <p:sp>
-        <p:nvSpPr>
-          <p:cNvPr id="19" name="TextBox 18"/>
+              <a:t>Normal Image Ingestion</a:t>
+            </a:r>
+          </a:p>
+        </p:txBody>
+      </p:sp>
+      <p:sp>
+        <p:nvSpPr>
+          <p:cNvPr id="40" name="TextBox 39"/>
           <p:cNvSpPr txBox="1"/>
           <p:nvPr/>
         </p:nvSpPr>
         <p:spPr>
           <a:xfrm>
-            <a:off x="685316" y="3567112"/>
-            <a:ext cx="1814586" cy="304800"/>
+            <a:off x="460530" y="2461319"/>
+            <a:ext cx="2157449" cy="462557"/>
           </a:xfrm>
           <a:prstGeom prst="rect">
             <a:avLst/>
@@ -5563,29 +6374,33 @@
           </a:bodyPr>
           <a:lstStyle/>
           <a:p>
-            <a:pPr algn="ctr"/>
-            <a:r>
-              <a:rPr sz="975" b="0" i="0" u="none">
+            <a:pPr algn="ctr">
+              <a:lnSpc>
+                <a:spcPts val="1214"/>
+              </a:lnSpc>
+            </a:pPr>
+            <a:r>
+              <a:rPr sz="900" b="0" i="0" u="none">
                 <a:solidFill>
                   <a:srgbClr val="64748B"/>
                 </a:solidFill>
-                <a:latin typeface="Plus Jakarta Sans"/>
+                <a:latin typeface="Inter"/>
               </a:rPr>
-              <a:t>900x900 to 300x300 area interpolation.</a:t>
-            </a:r>
-          </a:p>
-        </p:txBody>
-      </p:sp>
-      <p:sp>
-        <p:nvSpPr>
-          <p:cNvPr id="20" name="TextBox 19"/>
+              <a:t>209 defect-free 900x900 bottles downsampled to 300x300.</a:t>
+            </a:r>
+          </a:p>
+        </p:txBody>
+      </p:sp>
+      <p:sp>
+        <p:nvSpPr>
+          <p:cNvPr id="41" name="TextBox 40"/>
           <p:cNvSpPr txBox="1"/>
           <p:nvPr/>
         </p:nvSpPr>
         <p:spPr>
           <a:xfrm>
-            <a:off x="2937085" y="3100387"/>
-            <a:ext cx="1814586" cy="152400"/>
+            <a:off x="2738939" y="2041028"/>
+            <a:ext cx="2157449" cy="133350"/>
           </a:xfrm>
           <a:prstGeom prst="rect">
             <a:avLst/>
@@ -5600,27 +6415,27 @@
           <a:p>
             <a:pPr algn="ctr"/>
             <a:r>
-              <a:rPr sz="900" b="1" i="0" u="none">
+              <a:rPr sz="825" b="1" i="0" u="none">
                 <a:solidFill>
                   <a:srgbClr val="0284C7"/>
                 </a:solidFill>
-                <a:latin typeface="JetBrains Mono"/>
+                <a:latin typeface="Inter"/>
               </a:rPr>
-              <a:t>STEP 02</a:t>
-            </a:r>
-          </a:p>
-        </p:txBody>
-      </p:sp>
-      <p:sp>
-        <p:nvSpPr>
-          <p:cNvPr id="21" name="TextBox 20"/>
+              <a:t>STEP T2</a:t>
+            </a:r>
+          </a:p>
+        </p:txBody>
+      </p:sp>
+      <p:sp>
+        <p:nvSpPr>
+          <p:cNvPr id="42" name="TextBox 41"/>
           <p:cNvSpPr txBox="1"/>
           <p:nvPr/>
         </p:nvSpPr>
         <p:spPr>
           <a:xfrm>
-            <a:off x="2891721" y="3309937"/>
-            <a:ext cx="1905316" cy="200025"/>
+            <a:off x="2685003" y="2231528"/>
+            <a:ext cx="2265322" cy="172640"/>
           </a:xfrm>
           <a:prstGeom prst="rect">
             <a:avLst/>
@@ -5633,29 +6448,33 @@
           </a:bodyPr>
           <a:lstStyle/>
           <a:p>
-            <a:pPr algn="ctr"/>
-            <a:r>
-              <a:rPr sz="1200" b="1" i="0" u="none">
+            <a:pPr algn="ctr">
+              <a:lnSpc>
+                <a:spcPts val="1359"/>
+              </a:lnSpc>
+            </a:pPr>
+            <a:r>
+              <a:rPr sz="1087" b="1" i="0" u="none">
                 <a:solidFill>
                   <a:srgbClr val="0F172A"/>
                 </a:solidFill>
-                <a:latin typeface="Plus Jakarta Sans"/>
+                <a:latin typeface="Inter"/>
               </a:rPr>
-              <a:t>Circle Alignment</a:t>
-            </a:r>
-          </a:p>
-        </p:txBody>
-      </p:sp>
-      <p:sp>
-        <p:nvSpPr>
-          <p:cNvPr id="22" name="TextBox 21"/>
+              <a:t>Canonical Alignment</a:t>
+            </a:r>
+          </a:p>
+        </p:txBody>
+      </p:sp>
+      <p:sp>
+        <p:nvSpPr>
+          <p:cNvPr id="43" name="TextBox 42"/>
           <p:cNvSpPr txBox="1"/>
           <p:nvPr/>
         </p:nvSpPr>
         <p:spPr>
           <a:xfrm>
-            <a:off x="2937085" y="3567112"/>
-            <a:ext cx="1814586" cy="304800"/>
+            <a:off x="2738939" y="2461319"/>
+            <a:ext cx="2157449" cy="308371"/>
           </a:xfrm>
           <a:prstGeom prst="rect">
             <a:avLst/>
@@ -5668,29 +6487,33 @@
           </a:bodyPr>
           <a:lstStyle/>
           <a:p>
-            <a:pPr algn="ctr"/>
-            <a:r>
-              <a:rPr sz="975" b="0" i="0" u="none">
+            <a:pPr algn="ctr">
+              <a:lnSpc>
+                <a:spcPts val="1214"/>
+              </a:lnSpc>
+            </a:pPr>
+            <a:r>
+              <a:rPr sz="900" b="0" i="0" u="none">
                 <a:solidFill>
                   <a:srgbClr val="64748B"/>
                 </a:solidFill>
-                <a:latin typeface="Plus Jakarta Sans"/>
+                <a:latin typeface="Inter"/>
               </a:rPr>
-              <a:t>Enclosing circle to center at (150, 150).</a:t>
-            </a:r>
-          </a:p>
-        </p:txBody>
-      </p:sp>
-      <p:sp>
-        <p:nvSpPr>
-          <p:cNvPr id="23" name="TextBox 22"/>
+              <a:t>Centroid localization and affine warp translation to (150, 150).</a:t>
+            </a:r>
+          </a:p>
+        </p:txBody>
+      </p:sp>
+      <p:sp>
+        <p:nvSpPr>
+          <p:cNvPr id="44" name="TextBox 43"/>
           <p:cNvSpPr txBox="1"/>
           <p:nvPr/>
         </p:nvSpPr>
         <p:spPr>
           <a:xfrm>
-            <a:off x="5188855" y="3100387"/>
-            <a:ext cx="1814586" cy="152400"/>
+            <a:off x="5017349" y="2041028"/>
+            <a:ext cx="2157449" cy="133350"/>
           </a:xfrm>
           <a:prstGeom prst="rect">
             <a:avLst/>
@@ -5705,27 +6528,27 @@
           <a:p>
             <a:pPr algn="ctr"/>
             <a:r>
-              <a:rPr sz="900" b="1" i="0" u="none">
+              <a:rPr sz="825" b="1" i="0" u="none">
                 <a:solidFill>
                   <a:srgbClr val="0284C7"/>
                 </a:solidFill>
-                <a:latin typeface="JetBrains Mono"/>
+                <a:latin typeface="Inter"/>
               </a:rPr>
-              <a:t>STEP 03</a:t>
-            </a:r>
-          </a:p>
-        </p:txBody>
-      </p:sp>
-      <p:sp>
-        <p:nvSpPr>
-          <p:cNvPr id="24" name="TextBox 23"/>
+              <a:t>STEP T3</a:t>
+            </a:r>
+          </a:p>
+        </p:txBody>
+      </p:sp>
+      <p:sp>
+        <p:nvSpPr>
+          <p:cNvPr id="45" name="TextBox 44"/>
           <p:cNvSpPr txBox="1"/>
           <p:nvPr/>
         </p:nvSpPr>
         <p:spPr>
           <a:xfrm>
-            <a:off x="5143490" y="3309937"/>
-            <a:ext cx="1905316" cy="200025"/>
+            <a:off x="4963413" y="2231528"/>
+            <a:ext cx="2265322" cy="172640"/>
           </a:xfrm>
           <a:prstGeom prst="rect">
             <a:avLst/>
@@ -5738,29 +6561,33 @@
           </a:bodyPr>
           <a:lstStyle/>
           <a:p>
-            <a:pPr algn="ctr"/>
-            <a:r>
-              <a:rPr sz="1200" b="1" i="0" u="none">
+            <a:pPr algn="ctr">
+              <a:lnSpc>
+                <a:spcPts val="1359"/>
+              </a:lnSpc>
+            </a:pPr>
+            <a:r>
+              <a:rPr sz="1087" b="1" i="0" u="none">
                 <a:solidFill>
                   <a:srgbClr val="0F172A"/>
                 </a:solidFill>
-                <a:latin typeface="Plus Jakarta Sans"/>
+                <a:latin typeface="Inter"/>
               </a:rPr>
-              <a:t>9-Ch Extraction</a:t>
-            </a:r>
-          </a:p>
-        </p:txBody>
-      </p:sp>
-      <p:sp>
-        <p:nvSpPr>
-          <p:cNvPr id="25" name="TextBox 24"/>
+              <a:t>9-Ch Feature Tensor</a:t>
+            </a:r>
+          </a:p>
+        </p:txBody>
+      </p:sp>
+      <p:sp>
+        <p:nvSpPr>
+          <p:cNvPr id="46" name="TextBox 45"/>
           <p:cNvSpPr txBox="1"/>
           <p:nvPr/>
         </p:nvSpPr>
         <p:spPr>
           <a:xfrm>
-            <a:off x="5188855" y="3567112"/>
-            <a:ext cx="1814586" cy="304800"/>
+            <a:off x="5017349" y="2461319"/>
+            <a:ext cx="2157449" cy="462557"/>
           </a:xfrm>
           <a:prstGeom prst="rect">
             <a:avLst/>
@@ -5773,29 +6600,33 @@
           </a:bodyPr>
           <a:lstStyle/>
           <a:p>
-            <a:pPr algn="ctr"/>
-            <a:r>
-              <a:rPr sz="975" b="0" i="0" u="none">
+            <a:pPr algn="ctr">
+              <a:lnSpc>
+                <a:spcPts val="1214"/>
+              </a:lnSpc>
+            </a:pPr>
+            <a:r>
+              <a:rPr sz="900" b="0" i="0" u="none">
                 <a:solidFill>
                   <a:srgbClr val="64748B"/>
                 </a:solidFill>
-                <a:latin typeface="Plus Jakarta Sans"/>
+                <a:latin typeface="Inter"/>
               </a:rPr>
-              <a:t>Color, edges, and morphology filters.</a:t>
-            </a:r>
-          </a:p>
-        </p:txBody>
-      </p:sp>
-      <p:sp>
-        <p:nvSpPr>
-          <p:cNvPr id="26" name="TextBox 25"/>
+              <a:t>Color (LAB, HSV), edges (Sobel, Laplacian), texture &amp; morphology.</a:t>
+            </a:r>
+          </a:p>
+        </p:txBody>
+      </p:sp>
+      <p:sp>
+        <p:nvSpPr>
+          <p:cNvPr id="47" name="TextBox 46"/>
           <p:cNvSpPr txBox="1"/>
           <p:nvPr/>
         </p:nvSpPr>
         <p:spPr>
           <a:xfrm>
-            <a:off x="7440624" y="3100387"/>
-            <a:ext cx="1814586" cy="152400"/>
+            <a:off x="7295759" y="2041028"/>
+            <a:ext cx="2157449" cy="133350"/>
           </a:xfrm>
           <a:prstGeom prst="rect">
             <a:avLst/>
@@ -5810,27 +6641,27 @@
           <a:p>
             <a:pPr algn="ctr"/>
             <a:r>
-              <a:rPr sz="900" b="1" i="0" u="none">
+              <a:rPr sz="825" b="1" i="0" u="none">
                 <a:solidFill>
                   <a:srgbClr val="0284C7"/>
                 </a:solidFill>
-                <a:latin typeface="JetBrains Mono"/>
+                <a:latin typeface="Inter"/>
               </a:rPr>
-              <a:t>STEP 04</a:t>
-            </a:r>
-          </a:p>
-        </p:txBody>
-      </p:sp>
-      <p:sp>
-        <p:nvSpPr>
-          <p:cNvPr id="27" name="TextBox 26"/>
+              <a:t>STEP T4</a:t>
+            </a:r>
+          </a:p>
+        </p:txBody>
+      </p:sp>
+      <p:sp>
+        <p:nvSpPr>
+          <p:cNvPr id="48" name="TextBox 47"/>
           <p:cNvSpPr txBox="1"/>
           <p:nvPr/>
         </p:nvSpPr>
         <p:spPr>
           <a:xfrm>
-            <a:off x="7395260" y="3309937"/>
-            <a:ext cx="1905316" cy="200025"/>
+            <a:off x="7241823" y="2231528"/>
+            <a:ext cx="2265322" cy="172640"/>
           </a:xfrm>
           <a:prstGeom prst="rect">
             <a:avLst/>
@@ -5843,29 +6674,33 @@
           </a:bodyPr>
           <a:lstStyle/>
           <a:p>
-            <a:pPr algn="ctr"/>
-            <a:r>
-              <a:rPr sz="1200" b="1" i="0" u="none">
+            <a:pPr algn="ctr">
+              <a:lnSpc>
+                <a:spcPts val="1359"/>
+              </a:lnSpc>
+            </a:pPr>
+            <a:r>
+              <a:rPr sz="1087" b="1" i="0" u="none">
                 <a:solidFill>
                   <a:srgbClr val="0F172A"/>
                 </a:solidFill>
-                <a:latin typeface="Plus Jakarta Sans"/>
+                <a:latin typeface="Inter"/>
               </a:rPr>
-              <a:t>Anomaly Engine</a:t>
-            </a:r>
-          </a:p>
-        </p:txBody>
-      </p:sp>
-      <p:sp>
-        <p:nvSpPr>
-          <p:cNvPr id="28" name="TextBox 27"/>
+              <a:t>Statistical Modeling</a:t>
+            </a:r>
+          </a:p>
+        </p:txBody>
+      </p:sp>
+      <p:sp>
+        <p:nvSpPr>
+          <p:cNvPr id="49" name="TextBox 48"/>
           <p:cNvSpPr txBox="1"/>
           <p:nvPr/>
         </p:nvSpPr>
         <p:spPr>
           <a:xfrm>
-            <a:off x="7440624" y="3567112"/>
-            <a:ext cx="1814586" cy="304800"/>
+            <a:off x="7295759" y="2461319"/>
+            <a:ext cx="2157449" cy="462557"/>
           </a:xfrm>
           <a:prstGeom prst="rect">
             <a:avLst/>
@@ -5878,29 +6713,33 @@
           </a:bodyPr>
           <a:lstStyle/>
           <a:p>
-            <a:pPr algn="ctr"/>
-            <a:r>
-              <a:rPr sz="975" b="0" i="0" u="none">
+            <a:pPr algn="ctr">
+              <a:lnSpc>
+                <a:spcPts val="1214"/>
+              </a:lnSpc>
+            </a:pPr>
+            <a:r>
+              <a:rPr sz="900" b="0" i="0" u="none">
                 <a:solidFill>
                   <a:srgbClr val="64748B"/>
                 </a:solidFill>
-                <a:latin typeface="Plus Jakarta Sans"/>
+                <a:latin typeface="Inter"/>
               </a:rPr>
-              <a:t>Pixel-level baseline deviation score.</a:t>
-            </a:r>
-          </a:p>
-        </p:txBody>
-      </p:sp>
-      <p:sp>
-        <p:nvSpPr>
-          <p:cNvPr id="29" name="TextBox 28"/>
+              <a:t>Pixel-wise mean (μ) and regularized standard deviation (σ + ε).</a:t>
+            </a:r>
+          </a:p>
+        </p:txBody>
+      </p:sp>
+      <p:sp>
+        <p:nvSpPr>
+          <p:cNvPr id="50" name="TextBox 49"/>
           <p:cNvSpPr txBox="1"/>
           <p:nvPr/>
         </p:nvSpPr>
         <p:spPr>
           <a:xfrm>
-            <a:off x="9692394" y="3100387"/>
-            <a:ext cx="1814586" cy="152400"/>
+            <a:off x="9574169" y="2041028"/>
+            <a:ext cx="2157449" cy="133350"/>
           </a:xfrm>
           <a:prstGeom prst="rect">
             <a:avLst/>
@@ -5915,27 +6754,27 @@
           <a:p>
             <a:pPr algn="ctr"/>
             <a:r>
-              <a:rPr sz="900" b="1" i="0" u="none">
+              <a:rPr sz="825" b="1" i="0" u="none">
                 <a:solidFill>
                   <a:srgbClr val="0284C7"/>
                 </a:solidFill>
-                <a:latin typeface="JetBrains Mono"/>
+                <a:latin typeface="Inter"/>
               </a:rPr>
-              <a:t>STEP 05</a:t>
-            </a:r>
-          </a:p>
-        </p:txBody>
-      </p:sp>
-      <p:sp>
-        <p:nvSpPr>
-          <p:cNvPr id="30" name="TextBox 29"/>
+              <a:t>STEP T5</a:t>
+            </a:r>
+          </a:p>
+        </p:txBody>
+      </p:sp>
+      <p:sp>
+        <p:nvSpPr>
+          <p:cNvPr id="51" name="TextBox 50"/>
           <p:cNvSpPr txBox="1"/>
           <p:nvPr/>
         </p:nvSpPr>
         <p:spPr>
           <a:xfrm>
-            <a:off x="9647029" y="3309937"/>
-            <a:ext cx="1905316" cy="200025"/>
+            <a:off x="9520232" y="2231528"/>
+            <a:ext cx="2265322" cy="172640"/>
           </a:xfrm>
           <a:prstGeom prst="rect">
             <a:avLst/>
@@ -5948,29 +6787,33 @@
           </a:bodyPr>
           <a:lstStyle/>
           <a:p>
-            <a:pPr algn="ctr"/>
-            <a:r>
-              <a:rPr sz="1200" b="1" i="0" u="none">
+            <a:pPr algn="ctr">
+              <a:lnSpc>
+                <a:spcPts val="1359"/>
+              </a:lnSpc>
+            </a:pPr>
+            <a:r>
+              <a:rPr sz="1087" b="1" i="0" u="none">
                 <a:solidFill>
                   <a:srgbClr val="0F172A"/>
                 </a:solidFill>
-                <a:latin typeface="Plus Jakarta Sans"/>
+                <a:latin typeface="Inter"/>
               </a:rPr>
-              <a:t>3-Tier Decision</a:t>
-            </a:r>
-          </a:p>
-        </p:txBody>
-      </p:sp>
-      <p:sp>
-        <p:nvSpPr>
-          <p:cNvPr id="31" name="TextBox 30"/>
+              <a:t>Model Serialization</a:t>
+            </a:r>
+          </a:p>
+        </p:txBody>
+      </p:sp>
+      <p:sp>
+        <p:nvSpPr>
+          <p:cNvPr id="52" name="TextBox 51"/>
           <p:cNvSpPr txBox="1"/>
           <p:nvPr/>
         </p:nvSpPr>
         <p:spPr>
           <a:xfrm>
-            <a:off x="9692394" y="3567112"/>
-            <a:ext cx="1814586" cy="304800"/>
+            <a:off x="9574169" y="2461319"/>
+            <a:ext cx="2157449" cy="308371"/>
           </a:xfrm>
           <a:prstGeom prst="rect">
             <a:avLst/>
@@ -5983,29 +6826,33 @@
           </a:bodyPr>
           <a:lstStyle/>
           <a:p>
-            <a:pPr algn="ctr"/>
-            <a:r>
-              <a:rPr sz="975" b="0" i="0" u="none">
+            <a:pPr algn="ctr">
+              <a:lnSpc>
+                <a:spcPts val="1214"/>
+              </a:lnSpc>
+            </a:pPr>
+            <a:r>
+              <a:rPr sz="900" b="0" i="0" u="none">
                 <a:solidFill>
                   <a:srgbClr val="64748B"/>
                 </a:solidFill>
-                <a:latin typeface="Plus Jakarta Sans"/>
+                <a:latin typeface="Inter"/>
               </a:rPr>
-              <a:t>Pass, Review, or Defect rejection.</a:t>
-            </a:r>
-          </a:p>
-        </p:txBody>
-      </p:sp>
-      <p:sp>
-        <p:nvSpPr>
-          <p:cNvPr id="32" name="TextBox 31"/>
+              <a:t>Export 3.8 MB compressed baseline archive (.npz artifact).</a:t>
+            </a:r>
+          </a:p>
+        </p:txBody>
+      </p:sp>
+      <p:sp>
+        <p:nvSpPr>
+          <p:cNvPr id="53" name="TextBox 52"/>
           <p:cNvSpPr txBox="1"/>
           <p:nvPr/>
         </p:nvSpPr>
         <p:spPr>
           <a:xfrm>
-            <a:off x="866775" y="4357687"/>
-            <a:ext cx="6417468" cy="171450"/>
+            <a:off x="460530" y="4147691"/>
+            <a:ext cx="2157449" cy="133350"/>
           </a:xfrm>
           <a:prstGeom prst="rect">
             <a:avLst/>
@@ -6018,29 +6865,68 @@
           </a:bodyPr>
           <a:lstStyle/>
           <a:p>
-            <a:pPr algn="l"/>
-            <a:r>
-              <a:rPr sz="1050" b="1" i="0" u="none">
+            <a:pPr algn="ctr"/>
+            <a:r>
+              <a:rPr sz="825" b="1" i="0" u="none">
+                <a:solidFill>
+                  <a:srgbClr val="059669"/>
+                </a:solidFill>
+                <a:latin typeface="Inter"/>
+              </a:rPr>
+              <a:t>STEP I1</a:t>
+            </a:r>
+          </a:p>
+        </p:txBody>
+      </p:sp>
+      <p:sp>
+        <p:nvSpPr>
+          <p:cNvPr id="54" name="TextBox 53"/>
+          <p:cNvSpPr txBox="1"/>
+          <p:nvPr/>
+        </p:nvSpPr>
+        <p:spPr>
+          <a:xfrm>
+            <a:off x="406593" y="4338191"/>
+            <a:ext cx="2265322" cy="172640"/>
+          </a:xfrm>
+          <a:prstGeom prst="rect">
+            <a:avLst/>
+          </a:prstGeom>
+          <a:noFill/>
+        </p:spPr>
+        <p:txBody>
+          <a:bodyPr wrap="none" lIns="0" tIns="0" rIns="0" bIns="0" anchor="t">
+            <a:spAutoFit/>
+          </a:bodyPr>
+          <a:lstStyle/>
+          <a:p>
+            <a:pPr algn="ctr">
+              <a:lnSpc>
+                <a:spcPts val="1359"/>
+              </a:lnSpc>
+            </a:pPr>
+            <a:r>
+              <a:rPr sz="1087" b="1" i="0" u="none">
                 <a:solidFill>
                   <a:srgbClr val="0F172A"/>
                 </a:solidFill>
-                <a:latin typeface="Plus Jakarta Sans"/>
+                <a:latin typeface="Inter"/>
               </a:rPr>
-              <a:t>Affine Drift Correction</a:t>
-            </a:r>
-          </a:p>
-        </p:txBody>
-      </p:sp>
-      <p:sp>
-        <p:nvSpPr>
-          <p:cNvPr id="33" name="TextBox 32"/>
+              <a:t>Input &amp; Resizing</a:t>
+            </a:r>
+          </a:p>
+        </p:txBody>
+      </p:sp>
+      <p:sp>
+        <p:nvSpPr>
+          <p:cNvPr id="55" name="TextBox 54"/>
           <p:cNvSpPr txBox="1"/>
           <p:nvPr/>
         </p:nvSpPr>
         <p:spPr>
           <a:xfrm>
-            <a:off x="866775" y="4567237"/>
-            <a:ext cx="5229225" cy="304800"/>
+            <a:off x="460530" y="4567981"/>
+            <a:ext cx="2157449" cy="308371"/>
           </a:xfrm>
           <a:prstGeom prst="rect">
             <a:avLst/>
@@ -6053,29 +6939,33 @@
           </a:bodyPr>
           <a:lstStyle/>
           <a:p>
-            <a:pPr algn="l"/>
-            <a:r>
-              <a:rPr sz="975" b="0" i="0" u="none">
+            <a:pPr algn="ctr">
+              <a:lnSpc>
+                <a:spcPts val="1214"/>
+              </a:lnSpc>
+            </a:pPr>
+            <a:r>
+              <a:rPr sz="900" b="0" i="0" u="none">
                 <a:solidFill>
                   <a:srgbClr val="64748B"/>
                 </a:solidFill>
-                <a:latin typeface="Plus Jakarta Sans"/>
+                <a:latin typeface="Inter"/>
               </a:rPr>
-              <a:t>Cancels conveyor belt displacement down to sub-pixel coordinates before comparison.</a:t>
-            </a:r>
-          </a:p>
-        </p:txBody>
-      </p:sp>
-      <p:sp>
-        <p:nvSpPr>
-          <p:cNvPr id="34" name="TextBox 33"/>
+              <a:t>Conveyor frame resize to 300x300 area interpolation.</a:t>
+            </a:r>
+          </a:p>
+        </p:txBody>
+      </p:sp>
+      <p:sp>
+        <p:nvSpPr>
+          <p:cNvPr id="56" name="TextBox 55"/>
           <p:cNvSpPr txBox="1"/>
           <p:nvPr/>
         </p:nvSpPr>
         <p:spPr>
           <a:xfrm>
-            <a:off x="6372225" y="4357687"/>
-            <a:ext cx="5819775" cy="171450"/>
+            <a:off x="2738939" y="4147691"/>
+            <a:ext cx="2157449" cy="133350"/>
           </a:xfrm>
           <a:prstGeom prst="rect">
             <a:avLst/>
@@ -6088,29 +6978,107 @@
           </a:bodyPr>
           <a:lstStyle/>
           <a:p>
-            <a:pPr algn="l"/>
-            <a:r>
-              <a:rPr sz="1050" b="1" i="0" u="none">
+            <a:pPr algn="ctr"/>
+            <a:r>
+              <a:rPr sz="825" b="1" i="0" u="none">
+                <a:solidFill>
+                  <a:srgbClr val="059669"/>
+                </a:solidFill>
+                <a:latin typeface="Inter"/>
+              </a:rPr>
+              <a:t>STEP I2</a:t>
+            </a:r>
+          </a:p>
+        </p:txBody>
+      </p:sp>
+      <p:sp>
+        <p:nvSpPr>
+          <p:cNvPr id="57" name="TextBox 56"/>
+          <p:cNvSpPr txBox="1"/>
+          <p:nvPr/>
+        </p:nvSpPr>
+        <p:spPr>
+          <a:xfrm>
+            <a:off x="2685003" y="4338191"/>
+            <a:ext cx="2265322" cy="172640"/>
+          </a:xfrm>
+          <a:prstGeom prst="rect">
+            <a:avLst/>
+          </a:prstGeom>
+          <a:noFill/>
+        </p:spPr>
+        <p:txBody>
+          <a:bodyPr wrap="none" lIns="0" tIns="0" rIns="0" bIns="0" anchor="t">
+            <a:spAutoFit/>
+          </a:bodyPr>
+          <a:lstStyle/>
+          <a:p>
+            <a:pPr algn="ctr">
+              <a:lnSpc>
+                <a:spcPts val="1359"/>
+              </a:lnSpc>
+            </a:pPr>
+            <a:r>
+              <a:rPr sz="1087" b="1" i="0" u="none">
                 <a:solidFill>
                   <a:srgbClr val="0F172A"/>
                 </a:solidFill>
-                <a:latin typeface="Plus Jakarta Sans"/>
+                <a:latin typeface="Inter"/>
               </a:rPr>
-              <a:t>Statistical Pixel Variance</a:t>
-            </a:r>
-          </a:p>
-        </p:txBody>
-      </p:sp>
-      <p:sp>
-        <p:nvSpPr>
-          <p:cNvPr id="35" name="TextBox 34"/>
+              <a:t>Circle Alignment</a:t>
+            </a:r>
+          </a:p>
+        </p:txBody>
+      </p:sp>
+      <p:sp>
+        <p:nvSpPr>
+          <p:cNvPr id="58" name="TextBox 57"/>
           <p:cNvSpPr txBox="1"/>
           <p:nvPr/>
         </p:nvSpPr>
         <p:spPr>
           <a:xfrm>
-            <a:off x="6372225" y="4567237"/>
-            <a:ext cx="5819775" cy="152400"/>
+            <a:off x="2738939" y="4567981"/>
+            <a:ext cx="2157449" cy="462557"/>
+          </a:xfrm>
+          <a:prstGeom prst="rect">
+            <a:avLst/>
+          </a:prstGeom>
+          <a:noFill/>
+        </p:spPr>
+        <p:txBody>
+          <a:bodyPr wrap="square" lIns="0" tIns="0" rIns="0" bIns="0" anchor="t">
+            <a:spAutoFit/>
+          </a:bodyPr>
+          <a:lstStyle/>
+          <a:p>
+            <a:pPr algn="ctr">
+              <a:lnSpc>
+                <a:spcPts val="1214"/>
+              </a:lnSpc>
+            </a:pPr>
+            <a:r>
+              <a:rPr sz="900" b="0" i="0" u="none">
+                <a:solidFill>
+                  <a:srgbClr val="64748B"/>
+                </a:solidFill>
+                <a:latin typeface="Inter"/>
+              </a:rPr>
+              <a:t>Enclosing circle center translation to coordinate (150, 150).</a:t>
+            </a:r>
+          </a:p>
+        </p:txBody>
+      </p:sp>
+      <p:sp>
+        <p:nvSpPr>
+          <p:cNvPr id="59" name="TextBox 58"/>
+          <p:cNvSpPr txBox="1"/>
+          <p:nvPr/>
+        </p:nvSpPr>
+        <p:spPr>
+          <a:xfrm>
+            <a:off x="5017349" y="4147691"/>
+            <a:ext cx="2157449" cy="133350"/>
           </a:xfrm>
           <a:prstGeom prst="rect">
             <a:avLst/>
@@ -6123,15 +7091,319 @@
           </a:bodyPr>
           <a:lstStyle/>
           <a:p>
-            <a:pPr algn="l"/>
-            <a:r>
-              <a:rPr sz="975" b="0" i="0" u="none">
+            <a:pPr algn="ctr"/>
+            <a:r>
+              <a:rPr sz="825" b="1" i="0" u="none">
+                <a:solidFill>
+                  <a:srgbClr val="059669"/>
+                </a:solidFill>
+                <a:latin typeface="Inter"/>
+              </a:rPr>
+              <a:t>STEP I3</a:t>
+            </a:r>
+          </a:p>
+        </p:txBody>
+      </p:sp>
+      <p:sp>
+        <p:nvSpPr>
+          <p:cNvPr id="60" name="TextBox 59"/>
+          <p:cNvSpPr txBox="1"/>
+          <p:nvPr/>
+        </p:nvSpPr>
+        <p:spPr>
+          <a:xfrm>
+            <a:off x="4963413" y="4338191"/>
+            <a:ext cx="2265322" cy="172640"/>
+          </a:xfrm>
+          <a:prstGeom prst="rect">
+            <a:avLst/>
+          </a:prstGeom>
+          <a:noFill/>
+        </p:spPr>
+        <p:txBody>
+          <a:bodyPr wrap="none" lIns="0" tIns="0" rIns="0" bIns="0" anchor="t">
+            <a:spAutoFit/>
+          </a:bodyPr>
+          <a:lstStyle/>
+          <a:p>
+            <a:pPr algn="ctr">
+              <a:lnSpc>
+                <a:spcPts val="1359"/>
+              </a:lnSpc>
+            </a:pPr>
+            <a:r>
+              <a:rPr sz="1087" b="1" i="0" u="none">
+                <a:solidFill>
+                  <a:srgbClr val="0F172A"/>
+                </a:solidFill>
+                <a:latin typeface="Inter"/>
+              </a:rPr>
+              <a:t>9-Ch Extraction</a:t>
+            </a:r>
+          </a:p>
+        </p:txBody>
+      </p:sp>
+      <p:sp>
+        <p:nvSpPr>
+          <p:cNvPr id="61" name="TextBox 60"/>
+          <p:cNvSpPr txBox="1"/>
+          <p:nvPr/>
+        </p:nvSpPr>
+        <p:spPr>
+          <a:xfrm>
+            <a:off x="5017349" y="4567981"/>
+            <a:ext cx="2157449" cy="308371"/>
+          </a:xfrm>
+          <a:prstGeom prst="rect">
+            <a:avLst/>
+          </a:prstGeom>
+          <a:noFill/>
+        </p:spPr>
+        <p:txBody>
+          <a:bodyPr wrap="square" lIns="0" tIns="0" rIns="0" bIns="0" anchor="t">
+            <a:spAutoFit/>
+          </a:bodyPr>
+          <a:lstStyle/>
+          <a:p>
+            <a:pPr algn="ctr">
+              <a:lnSpc>
+                <a:spcPts val="1214"/>
+              </a:lnSpc>
+            </a:pPr>
+            <a:r>
+              <a:rPr sz="900" b="0" i="0" u="none">
                 <a:solidFill>
                   <a:srgbClr val="64748B"/>
                 </a:solidFill>
-                <a:latin typeface="Plus Jakarta Sans"/>
+                <a:latin typeface="Inter"/>
               </a:rPr>
-              <a:t>Models mean appearance and variance per coordinate across 209 normal bottles.</a:t>
+              <a:t>Matching 9-channel descriptor computation for test frame.</a:t>
+            </a:r>
+          </a:p>
+        </p:txBody>
+      </p:sp>
+      <p:sp>
+        <p:nvSpPr>
+          <p:cNvPr id="62" name="TextBox 61"/>
+          <p:cNvSpPr txBox="1"/>
+          <p:nvPr/>
+        </p:nvSpPr>
+        <p:spPr>
+          <a:xfrm>
+            <a:off x="7295759" y="4147691"/>
+            <a:ext cx="2157449" cy="133350"/>
+          </a:xfrm>
+          <a:prstGeom prst="rect">
+            <a:avLst/>
+          </a:prstGeom>
+          <a:noFill/>
+        </p:spPr>
+        <p:txBody>
+          <a:bodyPr wrap="none" lIns="0" tIns="0" rIns="0" bIns="0" anchor="t">
+            <a:spAutoFit/>
+          </a:bodyPr>
+          <a:lstStyle/>
+          <a:p>
+            <a:pPr algn="ctr"/>
+            <a:r>
+              <a:rPr sz="825" b="1" i="0" u="none">
+                <a:solidFill>
+                  <a:srgbClr val="059669"/>
+                </a:solidFill>
+                <a:latin typeface="Inter"/>
+              </a:rPr>
+              <a:t>STEP I4</a:t>
+            </a:r>
+          </a:p>
+        </p:txBody>
+      </p:sp>
+      <p:sp>
+        <p:nvSpPr>
+          <p:cNvPr id="63" name="TextBox 62"/>
+          <p:cNvSpPr txBox="1"/>
+          <p:nvPr/>
+        </p:nvSpPr>
+        <p:spPr>
+          <a:xfrm>
+            <a:off x="7241823" y="4338191"/>
+            <a:ext cx="2265322" cy="172640"/>
+          </a:xfrm>
+          <a:prstGeom prst="rect">
+            <a:avLst/>
+          </a:prstGeom>
+          <a:noFill/>
+        </p:spPr>
+        <p:txBody>
+          <a:bodyPr wrap="none" lIns="0" tIns="0" rIns="0" bIns="0" anchor="t">
+            <a:spAutoFit/>
+          </a:bodyPr>
+          <a:lstStyle/>
+          <a:p>
+            <a:pPr algn="ctr">
+              <a:lnSpc>
+                <a:spcPts val="1359"/>
+              </a:lnSpc>
+            </a:pPr>
+            <a:r>
+              <a:rPr sz="1087" b="1" i="0" u="none">
+                <a:solidFill>
+                  <a:srgbClr val="0F172A"/>
+                </a:solidFill>
+                <a:latin typeface="Inter"/>
+              </a:rPr>
+              <a:t>Mahalanobis Engine</a:t>
+            </a:r>
+          </a:p>
+        </p:txBody>
+      </p:sp>
+      <p:sp>
+        <p:nvSpPr>
+          <p:cNvPr id="64" name="TextBox 63"/>
+          <p:cNvSpPr txBox="1"/>
+          <p:nvPr/>
+        </p:nvSpPr>
+        <p:spPr>
+          <a:xfrm>
+            <a:off x="7295759" y="4567981"/>
+            <a:ext cx="2157449" cy="308371"/>
+          </a:xfrm>
+          <a:prstGeom prst="rect">
+            <a:avLst/>
+          </a:prstGeom>
+          <a:noFill/>
+        </p:spPr>
+        <p:txBody>
+          <a:bodyPr wrap="square" lIns="0" tIns="0" rIns="0" bIns="0" anchor="t">
+            <a:spAutoFit/>
+          </a:bodyPr>
+          <a:lstStyle/>
+          <a:p>
+            <a:pPr algn="ctr">
+              <a:lnSpc>
+                <a:spcPts val="1214"/>
+              </a:lnSpc>
+            </a:pPr>
+            <a:r>
+              <a:rPr sz="900" b="0" i="0" u="none">
+                <a:solidFill>
+                  <a:srgbClr val="64748B"/>
+                </a:solidFill>
+                <a:latin typeface="Inter"/>
+              </a:rPr>
+              <a:t>Weighted Z-score residual map and 99.8th percentile scoring.</a:t>
+            </a:r>
+          </a:p>
+        </p:txBody>
+      </p:sp>
+      <p:sp>
+        <p:nvSpPr>
+          <p:cNvPr id="65" name="TextBox 64"/>
+          <p:cNvSpPr txBox="1"/>
+          <p:nvPr/>
+        </p:nvSpPr>
+        <p:spPr>
+          <a:xfrm>
+            <a:off x="9574169" y="4147691"/>
+            <a:ext cx="2157449" cy="133350"/>
+          </a:xfrm>
+          <a:prstGeom prst="rect">
+            <a:avLst/>
+          </a:prstGeom>
+          <a:noFill/>
+        </p:spPr>
+        <p:txBody>
+          <a:bodyPr wrap="none" lIns="0" tIns="0" rIns="0" bIns="0" anchor="t">
+            <a:spAutoFit/>
+          </a:bodyPr>
+          <a:lstStyle/>
+          <a:p>
+            <a:pPr algn="ctr"/>
+            <a:r>
+              <a:rPr sz="825" b="1" i="0" u="none">
+                <a:solidFill>
+                  <a:srgbClr val="059669"/>
+                </a:solidFill>
+                <a:latin typeface="Inter"/>
+              </a:rPr>
+              <a:t>STEP I5</a:t>
+            </a:r>
+          </a:p>
+        </p:txBody>
+      </p:sp>
+      <p:sp>
+        <p:nvSpPr>
+          <p:cNvPr id="66" name="TextBox 65"/>
+          <p:cNvSpPr txBox="1"/>
+          <p:nvPr/>
+        </p:nvSpPr>
+        <p:spPr>
+          <a:xfrm>
+            <a:off x="9520232" y="4338191"/>
+            <a:ext cx="2265322" cy="172640"/>
+          </a:xfrm>
+          <a:prstGeom prst="rect">
+            <a:avLst/>
+          </a:prstGeom>
+          <a:noFill/>
+        </p:spPr>
+        <p:txBody>
+          <a:bodyPr wrap="none" lIns="0" tIns="0" rIns="0" bIns="0" anchor="t">
+            <a:spAutoFit/>
+          </a:bodyPr>
+          <a:lstStyle/>
+          <a:p>
+            <a:pPr algn="ctr">
+              <a:lnSpc>
+                <a:spcPts val="1359"/>
+              </a:lnSpc>
+            </a:pPr>
+            <a:r>
+              <a:rPr sz="1087" b="1" i="0" u="none">
+                <a:solidFill>
+                  <a:srgbClr val="0F172A"/>
+                </a:solidFill>
+                <a:latin typeface="Inter"/>
+              </a:rPr>
+              <a:t>3-Tier Decision</a:t>
+            </a:r>
+          </a:p>
+        </p:txBody>
+      </p:sp>
+      <p:sp>
+        <p:nvSpPr>
+          <p:cNvPr id="67" name="TextBox 66"/>
+          <p:cNvSpPr txBox="1"/>
+          <p:nvPr/>
+        </p:nvSpPr>
+        <p:spPr>
+          <a:xfrm>
+            <a:off x="9574169" y="4567981"/>
+            <a:ext cx="2157449" cy="308371"/>
+          </a:xfrm>
+          <a:prstGeom prst="rect">
+            <a:avLst/>
+          </a:prstGeom>
+          <a:noFill/>
+        </p:spPr>
+        <p:txBody>
+          <a:bodyPr wrap="square" lIns="0" tIns="0" rIns="0" bIns="0" anchor="t">
+            <a:spAutoFit/>
+          </a:bodyPr>
+          <a:lstStyle/>
+          <a:p>
+            <a:pPr algn="ctr">
+              <a:lnSpc>
+                <a:spcPts val="1214"/>
+              </a:lnSpc>
+            </a:pPr>
+            <a:r>
+              <a:rPr sz="900" b="0" i="0" u="none">
+                <a:solidFill>
+                  <a:srgbClr val="64748B"/>
+                </a:solidFill>
+                <a:latin typeface="Inter"/>
+              </a:rPr>
+              <a:t>Pass, Suspicious Review, or Reject with localized bbox.</a:t>
             </a:r>
           </a:p>
         </p:txBody>

</xml_diff>